<commit_message>
Update lab for workshop
</commit_message>
<xml_diff>
--- a/decks/Data-Modeling.pptx
+++ b/decks/Data-Modeling.pptx
@@ -153,6 +153,10 @@
           <p14:sldIdLst>
             <p14:sldId id="4591"/>
             <p14:sldId id="4658"/>
+          </p14:sldIdLst>
+        </p14:section>
+        <p14:section name="Data Modeling" id="{477FC9EE-A049-4C0A-BED2-D6C9EE47B258}">
+          <p14:sldIdLst>
             <p14:sldId id="4669"/>
             <p14:sldId id="1938"/>
             <p14:sldId id="4670"/>
@@ -175,6 +179,10 @@
             <p14:sldId id="4687"/>
             <p14:sldId id="4688"/>
             <p14:sldId id="4693"/>
+          </p14:sldIdLst>
+        </p14:section>
+        <p14:section name="Indexing" id="{323881A9-B575-4FC8-9FBF-E24F68F3CB12}">
+          <p14:sldIdLst>
             <p14:sldId id="4592"/>
             <p14:sldId id="4595"/>
             <p14:sldId id="1738"/>
@@ -319,7 +327,7 @@
               <a:rPr lang="en-US" smtClean="0">
                 <a:latin typeface="Arial" panose="020B0604020202020204" pitchFamily="34" charset="0"/>
               </a:rPr>
-              <a:t>5/30/2019</a:t>
+              <a:t>12/8/2025</a:t>
             </a:fld>
             <a:endParaRPr lang="en-US" dirty="0">
               <a:latin typeface="Arial" panose="020B0604020202020204" pitchFamily="34" charset="0"/>
@@ -509,7 +517,7 @@
             <a:fld id="{C3B508DD-CDB9-4EE9-8F98-E98C69349142}" type="datetimeFigureOut">
               <a:rPr lang="en-US" smtClean="0"/>
               <a:pPr/>
-              <a:t>5/30/2019</a:t>
+              <a:t>12/7/2025</a:t>
             </a:fld>
             <a:endParaRPr lang="en-US" dirty="0"/>
           </a:p>
@@ -2687,7 +2695,7 @@
           <a:p>
             <a:fld id="{D01120C9-890A-4013-ADCB-1DF4AE2150B6}" type="datetimeFigureOut">
               <a:rPr lang="en-US" smtClean="0"/>
-              <a:t>5/30/2019</a:t>
+              <a:t>12/7/2025</a:t>
             </a:fld>
             <a:endParaRPr lang="en-US"/>
           </a:p>
@@ -2862,7 +2870,7 @@
           <a:p>
             <a:fld id="{C764DE79-268F-4C1A-8933-263129D2AF90}" type="datetimeFigureOut">
               <a:rPr lang="en-US" smtClean="0"/>
-              <a:t>5/30/2019</a:t>
+              <a:t>12/7/2025</a:t>
             </a:fld>
             <a:endParaRPr lang="en-US" dirty="0"/>
           </a:p>
@@ -3042,7 +3050,7 @@
           <a:p>
             <a:fld id="{C764DE79-268F-4C1A-8933-263129D2AF90}" type="datetimeFigureOut">
               <a:rPr lang="en-US" smtClean="0"/>
-              <a:t>5/30/2019</a:t>
+              <a:t>12/7/2025</a:t>
             </a:fld>
             <a:endParaRPr lang="en-US" dirty="0"/>
           </a:p>
@@ -3822,7 +3830,7 @@
           <a:p>
             <a:fld id="{9912175C-3CF6-487A-9684-5B9CA6422935}" type="datetimeFigureOut">
               <a:rPr lang="en-US" smtClean="0"/>
-              <a:t>5/30/2019</a:t>
+              <a:t>12/7/2025</a:t>
             </a:fld>
             <a:endParaRPr lang="en-US"/>
           </a:p>
@@ -4068,7 +4076,7 @@
           <a:p>
             <a:fld id="{C764DE79-268F-4C1A-8933-263129D2AF90}" type="datetimeFigureOut">
               <a:rPr lang="en-US" smtClean="0"/>
-              <a:t>5/30/2019</a:t>
+              <a:t>12/7/2025</a:t>
             </a:fld>
             <a:endParaRPr lang="en-US" dirty="0"/>
           </a:p>
@@ -4300,7 +4308,7 @@
           <a:p>
             <a:fld id="{C764DE79-268F-4C1A-8933-263129D2AF90}" type="datetimeFigureOut">
               <a:rPr lang="en-US" smtClean="0"/>
-              <a:t>5/30/2019</a:t>
+              <a:t>12/7/2025</a:t>
             </a:fld>
             <a:endParaRPr lang="en-US" dirty="0"/>
           </a:p>
@@ -4667,7 +4675,7 @@
           <a:p>
             <a:fld id="{C764DE79-268F-4C1A-8933-263129D2AF90}" type="datetimeFigureOut">
               <a:rPr lang="en-US" smtClean="0"/>
-              <a:t>5/30/2019</a:t>
+              <a:t>12/7/2025</a:t>
             </a:fld>
             <a:endParaRPr lang="en-US" dirty="0"/>
           </a:p>
@@ -4785,7 +4793,7 @@
           <a:p>
             <a:fld id="{C764DE79-268F-4C1A-8933-263129D2AF90}" type="datetimeFigureOut">
               <a:rPr lang="en-US" smtClean="0"/>
-              <a:t>5/30/2019</a:t>
+              <a:t>12/7/2025</a:t>
             </a:fld>
             <a:endParaRPr lang="en-US" dirty="0"/>
           </a:p>
@@ -4883,7 +4891,7 @@
           <a:p>
             <a:fld id="{D01120C9-890A-4013-ADCB-1DF4AE2150B6}" type="datetimeFigureOut">
               <a:rPr lang="en-US" smtClean="0"/>
-              <a:t>5/30/2019</a:t>
+              <a:t>12/7/2025</a:t>
             </a:fld>
             <a:endParaRPr lang="en-US"/>
           </a:p>
@@ -5160,7 +5168,7 @@
           <a:p>
             <a:fld id="{C764DE79-268F-4C1A-8933-263129D2AF90}" type="datetimeFigureOut">
               <a:rPr lang="en-US" smtClean="0"/>
-              <a:t>5/30/2019</a:t>
+              <a:t>12/7/2025</a:t>
             </a:fld>
             <a:endParaRPr lang="en-US" dirty="0"/>
           </a:p>
@@ -5417,7 +5425,7 @@
           <a:p>
             <a:fld id="{C764DE79-268F-4C1A-8933-263129D2AF90}" type="datetimeFigureOut">
               <a:rPr lang="en-US" smtClean="0"/>
-              <a:t>5/30/2019</a:t>
+              <a:t>12/7/2025</a:t>
             </a:fld>
             <a:endParaRPr lang="en-US" dirty="0"/>
           </a:p>
@@ -5630,7 +5638,7 @@
           <a:p>
             <a:fld id="{C764DE79-268F-4C1A-8933-263129D2AF90}" type="datetimeFigureOut">
               <a:rPr lang="en-US" smtClean="0"/>
-              <a:t>5/30/2019</a:t>
+              <a:t>12/7/2025</a:t>
             </a:fld>
             <a:endParaRPr lang="en-US" dirty="0"/>
           </a:p>
@@ -50133,4 +50141,10 @@
     <ds:schemaRef ds:uri="http://schemas.microsoft.com/VisualStudio/2011/storyboarding/control"/>
   </ds:schemaRefs>
 </ds:datastoreItem>
+</file>
+
+<file path=docMetadata/LabelInfo.xml><?xml version="1.0" encoding="utf-8"?>
+<clbl:labelList xmlns:clbl="http://schemas.microsoft.com/office/2020/mipLabelMetadata">
+  <clbl:label id="{f42aa342-8706-4288-bd11-ebb85995028c}" enabled="1" method="Privileged" siteId="{72f988bf-86f1-41af-91ab-2d7cd011db47}" removed="0"/>
+</clbl:labelList>
 </file>
</xml_diff>